<commit_message>
Organized repo in the meeting.
</commit_message>
<xml_diff>
--- a/SE4003_U2_Presentation.pptx
+++ b/SE4003_U2_Presentation.pptx
@@ -5,11 +5,12 @@
     <p:sldMasterId id="2147483648" r:id="rId1"/>
   </p:sldMasterIdLst>
   <p:notesMasterIdLst>
-    <p:notesMasterId r:id="rId4"/>
+    <p:notesMasterId r:id="rId5"/>
   </p:notesMasterIdLst>
   <p:sldIdLst>
     <p:sldId id="256" r:id="rId2"/>
-    <p:sldId id="257" r:id="rId3"/>
+    <p:sldId id="258" r:id="rId3"/>
+    <p:sldId id="257" r:id="rId4"/>
   </p:sldIdLst>
   <p:sldSz cx="9144000" cy="6858000" type="screen4x3"/>
   <p:notesSz cx="6959600" cy="9309100"/>
@@ -258,7 +259,7 @@
       </p15:sldGuideLst>
     </p:ext>
     <p:ext uri="GoogleSlidesCustomDataVersion2">
-      <go:slidesCustomData xmlns:go="http://customooxmlschemas.google.com/" xmlns:ahyp="http://schemas.microsoft.com/office/drawing/2018/hyperlinkcolor" xmlns:p15="http://schemas.microsoft.com/office/powerpoint/2012/main" xmlns:p14="http://schemas.microsoft.com/office/powerpoint/2010/main" xmlns:com="http://schemas.openxmlformats.org/drawingml/2006/compatibility" xmlns:pvml="urn:schemas-microsoft-com:office:powerpoint" xmlns:v="urn:schemas-microsoft-com:vml" xmlns:o="urn:schemas-microsoft-com:office:office" xmlns:dgm="http://schemas.openxmlformats.org/drawingml/2006/diagram" xmlns:c="http://schemas.openxmlformats.org/drawingml/2006/chart" xmlns:mv="urn:schemas-microsoft-com:mac:vml" xmlns:mc="http://schemas.openxmlformats.org/markup-compatibility/2006" xmlns="" r:id="rId29" roundtripDataSignature="AMtx7mjr2lVQzyMabCgb+d8/5pLBIC5bJA=="/>
+      <go:slidesCustomData xmlns="" xmlns:mc="http://schemas.openxmlformats.org/markup-compatibility/2006" xmlns:mv="urn:schemas-microsoft-com:mac:vml" xmlns:c="http://schemas.openxmlformats.org/drawingml/2006/chart" xmlns:dgm="http://schemas.openxmlformats.org/drawingml/2006/diagram" xmlns:o="urn:schemas-microsoft-com:office:office" xmlns:v="urn:schemas-microsoft-com:vml" xmlns:pvml="urn:schemas-microsoft-com:office:powerpoint" xmlns:com="http://schemas.openxmlformats.org/drawingml/2006/compatibility" xmlns:p14="http://schemas.microsoft.com/office/powerpoint/2010/main" xmlns:p15="http://schemas.microsoft.com/office/powerpoint/2012/main" xmlns:ahyp="http://schemas.microsoft.com/office/drawing/2018/hyperlinkcolor" xmlns:go="http://customooxmlschemas.google.com/" r:id="rId29" roundtripDataSignature="AMtx7mjr2lVQzyMabCgb+d8/5pLBIC5bJA=="/>
     </p:ext>
   </p:extLst>
 </p:presentation>
@@ -2272,7 +2273,7 @@
             </a:pPr>
             <a:fld id="{00000000-1234-1234-1234-123412341234}" type="slidenum">
               <a:rPr lang="en-US"/>
-              <a:t>2</a:t>
+              <a:t>3</a:t>
             </a:fld>
             <a:endParaRPr/>
           </a:p>
@@ -14827,6 +14828,184 @@
   <p:cSld>
     <p:spTree>
       <p:nvGrpSpPr>
+        <p:cNvPr id="1" name=""/>
+        <p:cNvGrpSpPr/>
+        <p:nvPr/>
+      </p:nvGrpSpPr>
+      <p:grpSpPr>
+        <a:xfrm>
+          <a:off x="0" y="0"/>
+          <a:ext cx="0" cy="0"/>
+          <a:chOff x="0" y="0"/>
+          <a:chExt cx="0" cy="0"/>
+        </a:xfrm>
+      </p:grpSpPr>
+      <p:sp>
+        <p:nvSpPr>
+          <p:cNvPr id="5" name="Title 4">
+            <a:extLst>
+              <a:ext uri="{FF2B5EF4-FFF2-40B4-BE49-F238E27FC236}">
+                <a16:creationId xmlns:a16="http://schemas.microsoft.com/office/drawing/2014/main" id="{90508D33-07BF-0350-4BB9-8B304C3D4381}"/>
+              </a:ext>
+            </a:extLst>
+          </p:cNvPr>
+          <p:cNvSpPr>
+            <a:spLocks noGrp="1"/>
+          </p:cNvSpPr>
+          <p:nvPr>
+            <p:ph type="title"/>
+          </p:nvPr>
+        </p:nvSpPr>
+        <p:spPr/>
+        <p:txBody>
+          <a:bodyPr/>
+          <a:lstStyle/>
+          <a:p>
+            <a:endParaRPr lang="en-US"/>
+          </a:p>
+        </p:txBody>
+      </p:sp>
+      <p:sp>
+        <p:nvSpPr>
+          <p:cNvPr id="6" name="Text Placeholder 5">
+            <a:extLst>
+              <a:ext uri="{FF2B5EF4-FFF2-40B4-BE49-F238E27FC236}">
+                <a16:creationId xmlns:a16="http://schemas.microsoft.com/office/drawing/2014/main" id="{F6652168-3E43-7031-A1B5-A93ADB0140F8}"/>
+              </a:ext>
+            </a:extLst>
+          </p:cNvPr>
+          <p:cNvSpPr>
+            <a:spLocks noGrp="1"/>
+          </p:cNvSpPr>
+          <p:nvPr>
+            <p:ph type="body" idx="1"/>
+          </p:nvPr>
+        </p:nvSpPr>
+        <p:spPr/>
+        <p:txBody>
+          <a:bodyPr/>
+          <a:lstStyle/>
+          <a:p>
+            <a:r>
+              <a:rPr lang="en-US" dirty="0"/>
+              <a:t>Agenda</a:t>
+            </a:r>
+          </a:p>
+          <a:p>
+            <a:pPr lvl="1"/>
+            <a:r>
+              <a:rPr lang="en-US" dirty="0"/>
+              <a:t>Background (Justin)</a:t>
+            </a:r>
+          </a:p>
+          <a:p>
+            <a:pPr lvl="1"/>
+            <a:r>
+              <a:rPr lang="en-US" dirty="0"/>
+              <a:t>Requirements (Luke)</a:t>
+            </a:r>
+          </a:p>
+          <a:p>
+            <a:pPr lvl="1"/>
+            <a:r>
+              <a:rPr lang="en-US" dirty="0"/>
+              <a:t>Lit Review (Luke)</a:t>
+            </a:r>
+          </a:p>
+          <a:p>
+            <a:pPr lvl="1"/>
+            <a:r>
+              <a:rPr lang="en-US" dirty="0"/>
+              <a:t>Architecture (Dominic)</a:t>
+            </a:r>
+          </a:p>
+          <a:p>
+            <a:pPr lvl="1"/>
+            <a:r>
+              <a:rPr lang="en-US" dirty="0"/>
+              <a:t>UI (Matt)</a:t>
+            </a:r>
+          </a:p>
+          <a:p>
+            <a:pPr lvl="1"/>
+            <a:r>
+              <a:rPr lang="en-US" dirty="0"/>
+              <a:t>Code Re-use (Justin)</a:t>
+            </a:r>
+          </a:p>
+          <a:p>
+            <a:pPr lvl="1"/>
+            <a:r>
+              <a:rPr lang="en-US"/>
+              <a:t>Conclusions (Matt)</a:t>
+            </a:r>
+            <a:endParaRPr lang="en-US" dirty="0"/>
+          </a:p>
+          <a:p>
+            <a:pPr lvl="1"/>
+            <a:r>
+              <a:rPr lang="en-US" dirty="0"/>
+              <a:t>Questions</a:t>
+            </a:r>
+          </a:p>
+        </p:txBody>
+      </p:sp>
+      <p:sp>
+        <p:nvSpPr>
+          <p:cNvPr id="4" name="Slide Number Placeholder 3">
+            <a:extLst>
+              <a:ext uri="{FF2B5EF4-FFF2-40B4-BE49-F238E27FC236}">
+                <a16:creationId xmlns:a16="http://schemas.microsoft.com/office/drawing/2014/main" id="{7384FC0C-C8F3-9DAE-B015-C7CE02982FE9}"/>
+              </a:ext>
+            </a:extLst>
+          </p:cNvPr>
+          <p:cNvSpPr>
+            <a:spLocks noGrp="1"/>
+          </p:cNvSpPr>
+          <p:nvPr>
+            <p:ph type="sldNum" idx="12"/>
+          </p:nvPr>
+        </p:nvSpPr>
+        <p:spPr/>
+        <p:txBody>
+          <a:bodyPr/>
+          <a:lstStyle/>
+          <a:p>
+            <a:pPr marL="0" lvl="0" indent="0" algn="r" rtl="0">
+              <a:spcBef>
+                <a:spcPts val="0"/>
+              </a:spcBef>
+              <a:spcAft>
+                <a:spcPts val="0"/>
+              </a:spcAft>
+              <a:buNone/>
+            </a:pPr>
+            <a:fld id="{00000000-1234-1234-1234-123412341234}" type="slidenum">
+              <a:rPr lang="en-US" smtClean="0"/>
+              <a:t>2</a:t>
+            </a:fld>
+            <a:endParaRPr lang="en-US"/>
+          </a:p>
+        </p:txBody>
+      </p:sp>
+    </p:spTree>
+    <p:extLst>
+      <p:ext uri="{BB962C8B-B14F-4D97-AF65-F5344CB8AC3E}">
+        <p14:creationId xmlns:p14="http://schemas.microsoft.com/office/powerpoint/2010/main" val="3540579048"/>
+      </p:ext>
+    </p:extLst>
+  </p:cSld>
+  <p:clrMapOvr>
+    <a:masterClrMapping/>
+  </p:clrMapOvr>
+</p:sld>
+</file>
+
+<file path=ppt/slides/slide3.xml><?xml version="1.0" encoding="utf-8"?>
+<p:sld xmlns:a="http://schemas.openxmlformats.org/drawingml/2006/main" xmlns:r="http://schemas.openxmlformats.org/officeDocument/2006/relationships" xmlns:p="http://schemas.openxmlformats.org/presentationml/2006/main">
+  <p:cSld>
+    <p:spTree>
+      <p:nvGrpSpPr>
         <p:cNvPr id="1" name="Shape 102"/>
         <p:cNvGrpSpPr/>
         <p:nvPr/>
@@ -14987,7 +15166,7 @@
             </a:pPr>
             <a:fld id="{00000000-1234-1234-1234-123412341234}" type="slidenum">
               <a:rPr lang="en-US"/>
-              <a:t>2</a:t>
+              <a:t>3</a:t>
             </a:fld>
             <a:endParaRPr/>
           </a:p>

</xml_diff>